<commit_message>
Reorder epistemology deck to match three-movement arc; fix two citations
Companion presentation for Knowledge-Knower-And-Known (deck only; study
markdown unchanged).

Flow: move the §1.5 justice slide out of Movement 1 into Movement 3 and
raise the §1.10 "scope of the known" slide to close Movement 1, so slides
follow the three-movement arc declared on the orientation slide
(what knowledge is/known -> how jeevan knows -> how understanding becomes
evidence). The evaluation/justice/evidence theme is now contiguous.

Citations:
- Error slide: add MVD p. 184 for the false-learning definition
  (matches the study correction merged in PR #167).
- Fork slide: add JV p. 73 for the four-and-a-half activities enumeration.

Regenerated the companion PDF via Scripts/_pptx_to_pdf.py (PowerPoint engine).

Co-Authored-By: Claude Opus 4.8 <noreply@anthropic.com>
</commit_message>
<xml_diff>
--- a/Studies/Knowledge-Knower-And-Known/The-Epistemology-of-Coexistence-Madhyasth-Darshan.pptx
+++ b/Studies/Knowledge-Knower-And-Known/The-Epistemology-of-Coexistence-Madhyasth-Darshan.pptx
@@ -14,12 +14,12 @@
     <p:sldId xmlns:r="http://schemas.openxmlformats.org/officeDocument/2006/relationships" id="259" r:id="Rac4571156b604541"/>
     <p:sldId xmlns:r="http://schemas.openxmlformats.org/officeDocument/2006/relationships" id="260" r:id="R6036892bb280430e"/>
     <p:sldId xmlns:r="http://schemas.openxmlformats.org/officeDocument/2006/relationships" id="261" r:id="Rd35e176bdb444c40"/>
-    <p:sldId xmlns:r="http://schemas.openxmlformats.org/officeDocument/2006/relationships" id="262" r:id="R79896db618144699"/>
     <p:sldId xmlns:r="http://schemas.openxmlformats.org/officeDocument/2006/relationships" id="263" r:id="R47cf71ebb9c545cd"/>
     <p:sldId xmlns:r="http://schemas.openxmlformats.org/officeDocument/2006/relationships" id="264" r:id="R43343142a4af49aa"/>
     <p:sldId xmlns:r="http://schemas.openxmlformats.org/officeDocument/2006/relationships" id="265" r:id="Rb84ec2567e7e4e9a"/>
     <p:sldId xmlns:r="http://schemas.openxmlformats.org/officeDocument/2006/relationships" id="266" r:id="Rf9089cf1c0764f78"/>
     <p:sldId xmlns:r="http://schemas.openxmlformats.org/officeDocument/2006/relationships" id="267" r:id="Rb35d4214bd104ca5"/>
+    <p:sldId xmlns:r="http://schemas.openxmlformats.org/officeDocument/2006/relationships" id="262" r:id="R79896db618144699"/>
     <p:sldId xmlns:r="http://schemas.openxmlformats.org/officeDocument/2006/relationships" id="268" r:id="R35cb6fe088244230"/>
     <p:sldId xmlns:r="http://schemas.openxmlformats.org/officeDocument/2006/relationships" id="269" r:id="R3e10ed02ca784109"/>
     <p:sldId xmlns:r="http://schemas.openxmlformats.org/officeDocument/2006/relationships" id="270" r:id="R90b22261add844c3"/>
@@ -8064,7 +8064,7 @@
                 <a:ea typeface="Calibri"/>
                 <a:cs typeface="Calibri"/>
               </a:rPr>
-              <a:t>JV pp. 92–93  ·  KD §3.17  ·  MVD pp. 263–264</a:t>
+              <a:t>JV pp. 73, 92–93  ·  KD §3.17  ·  MVD pp. 263–264</a:t>
             </a:r>
           </a:p>
         </p:txBody>
@@ -17467,7 +17467,7 @@
                 <a:ea typeface="Calibri"/>
                 <a:cs typeface="Calibri"/>
               </a:rPr>
-              <a:t>JV p. 93  ·  MVD pp. 209, 263–264, 273–301, 317</a:t>
+              <a:t>JV p. 93  ·  MVD pp. 184, 209, 263–264, 273–301, 317</a:t>
             </a:r>
           </a:p>
         </p:txBody>

</xml_diff>

<commit_message>
Fix slide 4 text hierarchy
</commit_message>
<xml_diff>
--- a/Studies/Knowledge-Knower-And-Known/The-Epistemology-of-Coexistence-Madhyasth-Darshan.pptx
+++ b/Studies/Knowledge-Knower-And-Known/The-Epistemology-of-Coexistence-Madhyasth-Darshan.pptx
@@ -2,37 +2,37 @@
 <file path=ppt/presentation.xml><?xml version="1.0" encoding="utf-8"?>
 <p:presentation xmlns:p="http://schemas.openxmlformats.org/presentationml/2006/main">
   <p:sldMasterIdLst>
-    <p:sldMasterId xmlns:r="http://schemas.openxmlformats.org/officeDocument/2006/relationships" id="2147483648" r:id="R2af2ce6293304fdf"/>
+    <p:sldMasterId xmlns:r="http://schemas.openxmlformats.org/officeDocument/2006/relationships" id="2147483648" r:id="R4f59195fcc63413c"/>
   </p:sldMasterIdLst>
   <p:notesMasterIdLst>
-    <p:notesMasterId xmlns:r="http://schemas.openxmlformats.org/officeDocument/2006/relationships" r:id="Re910150711a94b31"/>
+    <p:notesMasterId xmlns:r="http://schemas.openxmlformats.org/officeDocument/2006/relationships" r:id="Rf937469b449740db"/>
   </p:notesMasterIdLst>
   <p:sldIdLst>
-    <p:sldId xmlns:r="http://schemas.openxmlformats.org/officeDocument/2006/relationships" id="256" r:id="R88de15396a7b469e"/>
-    <p:sldId xmlns:r="http://schemas.openxmlformats.org/officeDocument/2006/relationships" id="257" r:id="Ra0e73e8df8824e31"/>
-    <p:sldId xmlns:r="http://schemas.openxmlformats.org/officeDocument/2006/relationships" id="258" r:id="R613cbb91167c49e1"/>
-    <p:sldId xmlns:r="http://schemas.openxmlformats.org/officeDocument/2006/relationships" id="259" r:id="Rb5674eb9416948f6"/>
-    <p:sldId xmlns:r="http://schemas.openxmlformats.org/officeDocument/2006/relationships" id="260" r:id="Rabce1cfa6e394b36"/>
-    <p:sldId xmlns:r="http://schemas.openxmlformats.org/officeDocument/2006/relationships" id="261" r:id="R1de79eec10764f76"/>
-    <p:sldId xmlns:r="http://schemas.openxmlformats.org/officeDocument/2006/relationships" id="262" r:id="Rfe5e3edae0714ff8"/>
-    <p:sldId xmlns:r="http://schemas.openxmlformats.org/officeDocument/2006/relationships" id="263" r:id="R2eb474ccd11142a5"/>
-    <p:sldId xmlns:r="http://schemas.openxmlformats.org/officeDocument/2006/relationships" id="264" r:id="R422faf82e22e4eab"/>
-    <p:sldId xmlns:r="http://schemas.openxmlformats.org/officeDocument/2006/relationships" id="265" r:id="R9d783485b95640b6"/>
-    <p:sldId xmlns:r="http://schemas.openxmlformats.org/officeDocument/2006/relationships" id="266" r:id="R94f99743a03540dc"/>
-    <p:sldId xmlns:r="http://schemas.openxmlformats.org/officeDocument/2006/relationships" id="267" r:id="R71ba03dacb1741cd"/>
-    <p:sldId xmlns:r="http://schemas.openxmlformats.org/officeDocument/2006/relationships" id="268" r:id="R6c1c16ba14de427b"/>
-    <p:sldId xmlns:r="http://schemas.openxmlformats.org/officeDocument/2006/relationships" id="269" r:id="Rb1de57b79a4b4810"/>
-    <p:sldId xmlns:r="http://schemas.openxmlformats.org/officeDocument/2006/relationships" id="270" r:id="Rde2fa3dfde5d41f0"/>
-    <p:sldId xmlns:r="http://schemas.openxmlformats.org/officeDocument/2006/relationships" id="271" r:id="R8674896e760e4939"/>
-    <p:sldId xmlns:r="http://schemas.openxmlformats.org/officeDocument/2006/relationships" id="272" r:id="Rd25dedef6f514602"/>
-    <p:sldId xmlns:r="http://schemas.openxmlformats.org/officeDocument/2006/relationships" id="273" r:id="R79f41b38d4f74e82"/>
-    <p:sldId xmlns:r="http://schemas.openxmlformats.org/officeDocument/2006/relationships" id="274" r:id="Rf1703293b4f84c74"/>
-    <p:sldId xmlns:r="http://schemas.openxmlformats.org/officeDocument/2006/relationships" id="275" r:id="R9b8e51aeaa54480a"/>
-    <p:sldId xmlns:r="http://schemas.openxmlformats.org/officeDocument/2006/relationships" id="276" r:id="R145f09ce8dec42c3"/>
-    <p:sldId xmlns:r="http://schemas.openxmlformats.org/officeDocument/2006/relationships" id="277" r:id="R48f8f9790e9641d0"/>
-    <p:sldId xmlns:r="http://schemas.openxmlformats.org/officeDocument/2006/relationships" id="278" r:id="R26be952943164a27"/>
-    <p:sldId xmlns:r="http://schemas.openxmlformats.org/officeDocument/2006/relationships" id="279" r:id="R29abe43f37c54b44"/>
-    <p:sldId xmlns:r="http://schemas.openxmlformats.org/officeDocument/2006/relationships" id="280" r:id="Reb0913a8526f42ba"/>
+    <p:sldId xmlns:r="http://schemas.openxmlformats.org/officeDocument/2006/relationships" id="256" r:id="R3d10b6dd5d5940e4"/>
+    <p:sldId xmlns:r="http://schemas.openxmlformats.org/officeDocument/2006/relationships" id="257" r:id="Rc02558c222cc4b3a"/>
+    <p:sldId xmlns:r="http://schemas.openxmlformats.org/officeDocument/2006/relationships" id="258" r:id="Rdecc655ec6194e41"/>
+    <p:sldId xmlns:r="http://schemas.openxmlformats.org/officeDocument/2006/relationships" id="259" r:id="Reb40531f08b041c5"/>
+    <p:sldId xmlns:r="http://schemas.openxmlformats.org/officeDocument/2006/relationships" id="260" r:id="Rda3d4acc081a402a"/>
+    <p:sldId xmlns:r="http://schemas.openxmlformats.org/officeDocument/2006/relationships" id="261" r:id="Rbeb106c38e924f37"/>
+    <p:sldId xmlns:r="http://schemas.openxmlformats.org/officeDocument/2006/relationships" id="262" r:id="R6845677c0a9e45eb"/>
+    <p:sldId xmlns:r="http://schemas.openxmlformats.org/officeDocument/2006/relationships" id="263" r:id="Rf86d1839687a435c"/>
+    <p:sldId xmlns:r="http://schemas.openxmlformats.org/officeDocument/2006/relationships" id="264" r:id="Ref430fc45018466b"/>
+    <p:sldId xmlns:r="http://schemas.openxmlformats.org/officeDocument/2006/relationships" id="265" r:id="Ra2803367135a4494"/>
+    <p:sldId xmlns:r="http://schemas.openxmlformats.org/officeDocument/2006/relationships" id="266" r:id="Ra01737c8a9904be1"/>
+    <p:sldId xmlns:r="http://schemas.openxmlformats.org/officeDocument/2006/relationships" id="267" r:id="Rf035dd5918014ce7"/>
+    <p:sldId xmlns:r="http://schemas.openxmlformats.org/officeDocument/2006/relationships" id="268" r:id="R97b2caab4da04590"/>
+    <p:sldId xmlns:r="http://schemas.openxmlformats.org/officeDocument/2006/relationships" id="269" r:id="R6241604802ef4085"/>
+    <p:sldId xmlns:r="http://schemas.openxmlformats.org/officeDocument/2006/relationships" id="270" r:id="Rfe9d048670704cdc"/>
+    <p:sldId xmlns:r="http://schemas.openxmlformats.org/officeDocument/2006/relationships" id="271" r:id="Rd5bd50370848474f"/>
+    <p:sldId xmlns:r="http://schemas.openxmlformats.org/officeDocument/2006/relationships" id="272" r:id="Rf3dfa5739e7340e1"/>
+    <p:sldId xmlns:r="http://schemas.openxmlformats.org/officeDocument/2006/relationships" id="273" r:id="R6eeb111ee54c4c21"/>
+    <p:sldId xmlns:r="http://schemas.openxmlformats.org/officeDocument/2006/relationships" id="274" r:id="R2d9d7a6d519b4e6b"/>
+    <p:sldId xmlns:r="http://schemas.openxmlformats.org/officeDocument/2006/relationships" id="275" r:id="R827c59b404ac407e"/>
+    <p:sldId xmlns:r="http://schemas.openxmlformats.org/officeDocument/2006/relationships" id="276" r:id="R4748cb2170a947f3"/>
+    <p:sldId xmlns:r="http://schemas.openxmlformats.org/officeDocument/2006/relationships" id="277" r:id="R9086edb7a09c47f9"/>
+    <p:sldId xmlns:r="http://schemas.openxmlformats.org/officeDocument/2006/relationships" id="278" r:id="R9346f91c5a9542e1"/>
+    <p:sldId xmlns:r="http://schemas.openxmlformats.org/officeDocument/2006/relationships" id="279" r:id="Rce6093d0c3254f61"/>
+    <p:sldId xmlns:r="http://schemas.openxmlformats.org/officeDocument/2006/relationships" id="280" r:id="R66fc5cc2494d44e5"/>
   </p:sldIdLst>
   <p:sldSz cx="9144000" cy="5143500"/>
   <p:notesSz cx="6858000" cy="9144000"/>
@@ -2510,7 +2510,7 @@
   </p:cSld>
   <p:clrMap bg1="lt1" tx1="dk1" bg2="dk2" tx2="lt2" accent1="accent1" accent2="accent2" accent3="accent3" accent4="accent4" accent5="accent5" accent6="accent6" hlink="hlink" folHlink="folHlink"/>
   <p:sldLayoutIdLst>
-    <p:sldLayoutId xmlns:r="http://schemas.openxmlformats.org/officeDocument/2006/relationships" id="2147483649" r:id="Rfc982f751a784182"/>
+    <p:sldLayoutId xmlns:r="http://schemas.openxmlformats.org/officeDocument/2006/relationships" id="2147483649" r:id="R7e6c5bb537a54d55"/>
   </p:sldLayoutIdLst>
   <p:hf sldNum="0" hdr="0" ftr="0" dt="0"/>
   <p:txStyles>
@@ -22421,7 +22421,7 @@
           <p:nvPr/>
         </p:nvPicPr>
         <p:blipFill rotWithShape="1">
-          <a:blip xmlns:r="http://schemas.openxmlformats.org/officeDocument/2006/relationships" xmlns:a="http://schemas.openxmlformats.org/drawingml/2006/main" r:embed="R53758adcbaf34a94">
+          <a:blip xmlns:r="http://schemas.openxmlformats.org/officeDocument/2006/relationships" xmlns:a="http://schemas.openxmlformats.org/drawingml/2006/main" r:embed="Rdb3e6eca375c46a2">
             <a:alphaModFix/>
           </a:blip>
           <a:srcRect xmlns:a="http://schemas.openxmlformats.org/drawingml/2006/main" l="0" t="0" r="0" b="0"/>
@@ -22552,7 +22552,7 @@
           <p:nvPr/>
         </p:nvPicPr>
         <p:blipFill rotWithShape="1">
-          <a:blip xmlns:r="http://schemas.openxmlformats.org/officeDocument/2006/relationships" xmlns:a="http://schemas.openxmlformats.org/drawingml/2006/main" r:embed="R53758adcbaf34a94">
+          <a:blip xmlns:r="http://schemas.openxmlformats.org/officeDocument/2006/relationships" xmlns:a="http://schemas.openxmlformats.org/drawingml/2006/main" r:embed="Rdb3e6eca375c46a2">
             <a:alphaModFix/>
           </a:blip>
           <a:srcRect xmlns:a="http://schemas.openxmlformats.org/drawingml/2006/main" l="0" t="0" r="0" b="0"/>
@@ -22683,7 +22683,7 @@
           <p:nvPr/>
         </p:nvPicPr>
         <p:blipFill rotWithShape="1">
-          <a:blip xmlns:r="http://schemas.openxmlformats.org/officeDocument/2006/relationships" xmlns:a="http://schemas.openxmlformats.org/drawingml/2006/main" r:embed="R53758adcbaf34a94">
+          <a:blip xmlns:r="http://schemas.openxmlformats.org/officeDocument/2006/relationships" xmlns:a="http://schemas.openxmlformats.org/drawingml/2006/main" r:embed="Rdb3e6eca375c46a2">
             <a:alphaModFix/>
           </a:blip>
           <a:srcRect xmlns:a="http://schemas.openxmlformats.org/drawingml/2006/main" l="0" t="0" r="0" b="0"/>
@@ -22814,7 +22814,7 @@
           <p:nvPr/>
         </p:nvPicPr>
         <p:blipFill rotWithShape="1">
-          <a:blip xmlns:r="http://schemas.openxmlformats.org/officeDocument/2006/relationships" xmlns:a="http://schemas.openxmlformats.org/drawingml/2006/main" r:embed="R53758adcbaf34a94">
+          <a:blip xmlns:r="http://schemas.openxmlformats.org/officeDocument/2006/relationships" xmlns:a="http://schemas.openxmlformats.org/drawingml/2006/main" r:embed="Rdb3e6eca375c46a2">
             <a:alphaModFix/>
           </a:blip>
           <a:srcRect xmlns:a="http://schemas.openxmlformats.org/drawingml/2006/main" l="0" t="0" r="0" b="0"/>
@@ -22945,7 +22945,7 @@
           <p:nvPr/>
         </p:nvPicPr>
         <p:blipFill rotWithShape="1">
-          <a:blip xmlns:r="http://schemas.openxmlformats.org/officeDocument/2006/relationships" xmlns:a="http://schemas.openxmlformats.org/drawingml/2006/main" r:embed="R53758adcbaf34a94">
+          <a:blip xmlns:r="http://schemas.openxmlformats.org/officeDocument/2006/relationships" xmlns:a="http://schemas.openxmlformats.org/drawingml/2006/main" r:embed="Rdb3e6eca375c46a2">
             <a:alphaModFix/>
           </a:blip>
           <a:srcRect xmlns:a="http://schemas.openxmlformats.org/drawingml/2006/main" l="0" t="0" r="0" b="0"/>
@@ -23076,7 +23076,7 @@
           <p:nvPr/>
         </p:nvPicPr>
         <p:blipFill rotWithShape="1">
-          <a:blip xmlns:r="http://schemas.openxmlformats.org/officeDocument/2006/relationships" xmlns:a="http://schemas.openxmlformats.org/drawingml/2006/main" r:embed="R53758adcbaf34a94">
+          <a:blip xmlns:r="http://schemas.openxmlformats.org/officeDocument/2006/relationships" xmlns:a="http://schemas.openxmlformats.org/drawingml/2006/main" r:embed="Rdb3e6eca375c46a2">
             <a:alphaModFix/>
           </a:blip>
           <a:srcRect xmlns:a="http://schemas.openxmlformats.org/drawingml/2006/main" l="0" t="0" r="0" b="0"/>
@@ -24889,7 +24889,7 @@
           <p:nvPr/>
         </p:nvPicPr>
         <p:blipFill rotWithShape="1">
-          <a:blip xmlns:r="http://schemas.openxmlformats.org/officeDocument/2006/relationships" xmlns:a="http://schemas.openxmlformats.org/drawingml/2006/main" r:embed="R90b0a71d55af4267">
+          <a:blip xmlns:r="http://schemas.openxmlformats.org/officeDocument/2006/relationships" xmlns:a="http://schemas.openxmlformats.org/drawingml/2006/main" r:embed="R090b82bb23214242">
             <a:alphaModFix/>
           </a:blip>
           <a:srcRect xmlns:a="http://schemas.openxmlformats.org/drawingml/2006/main" l="0" t="0" r="0" b="0"/>
@@ -25020,7 +25020,7 @@
           <p:nvPr/>
         </p:nvPicPr>
         <p:blipFill rotWithShape="1">
-          <a:blip xmlns:r="http://schemas.openxmlformats.org/officeDocument/2006/relationships" xmlns:a="http://schemas.openxmlformats.org/drawingml/2006/main" r:embed="R90b0a71d55af4267">
+          <a:blip xmlns:r="http://schemas.openxmlformats.org/officeDocument/2006/relationships" xmlns:a="http://schemas.openxmlformats.org/drawingml/2006/main" r:embed="R090b82bb23214242">
             <a:alphaModFix/>
           </a:blip>
           <a:srcRect xmlns:a="http://schemas.openxmlformats.org/drawingml/2006/main" l="0" t="0" r="0" b="0"/>
@@ -25151,7 +25151,7 @@
           <p:nvPr/>
         </p:nvPicPr>
         <p:blipFill rotWithShape="1">
-          <a:blip xmlns:r="http://schemas.openxmlformats.org/officeDocument/2006/relationships" xmlns:a="http://schemas.openxmlformats.org/drawingml/2006/main" r:embed="R90b0a71d55af4267">
+          <a:blip xmlns:r="http://schemas.openxmlformats.org/officeDocument/2006/relationships" xmlns:a="http://schemas.openxmlformats.org/drawingml/2006/main" r:embed="R090b82bb23214242">
             <a:alphaModFix/>
           </a:blip>
           <a:srcRect xmlns:a="http://schemas.openxmlformats.org/drawingml/2006/main" l="0" t="0" r="0" b="0"/>
@@ -25282,7 +25282,7 @@
           <p:nvPr/>
         </p:nvPicPr>
         <p:blipFill rotWithShape="1">
-          <a:blip xmlns:r="http://schemas.openxmlformats.org/officeDocument/2006/relationships" xmlns:a="http://schemas.openxmlformats.org/drawingml/2006/main" r:embed="R90b0a71d55af4267">
+          <a:blip xmlns:r="http://schemas.openxmlformats.org/officeDocument/2006/relationships" xmlns:a="http://schemas.openxmlformats.org/drawingml/2006/main" r:embed="R090b82bb23214242">
             <a:alphaModFix/>
           </a:blip>
           <a:srcRect xmlns:a="http://schemas.openxmlformats.org/drawingml/2006/main" l="0" t="0" r="0" b="0"/>
@@ -25413,7 +25413,7 @@
           <p:nvPr/>
         </p:nvPicPr>
         <p:blipFill rotWithShape="1">
-          <a:blip xmlns:r="http://schemas.openxmlformats.org/officeDocument/2006/relationships" xmlns:a="http://schemas.openxmlformats.org/drawingml/2006/main" r:embed="R90b0a71d55af4267">
+          <a:blip xmlns:r="http://schemas.openxmlformats.org/officeDocument/2006/relationships" xmlns:a="http://schemas.openxmlformats.org/drawingml/2006/main" r:embed="R090b82bb23214242">
             <a:alphaModFix/>
           </a:blip>
           <a:srcRect xmlns:a="http://schemas.openxmlformats.org/drawingml/2006/main" l="0" t="0" r="0" b="0"/>
@@ -25544,7 +25544,7 @@
           <p:nvPr/>
         </p:nvPicPr>
         <p:blipFill rotWithShape="1">
-          <a:blip xmlns:r="http://schemas.openxmlformats.org/officeDocument/2006/relationships" xmlns:a="http://schemas.openxmlformats.org/drawingml/2006/main" r:embed="R90b0a71d55af4267">
+          <a:blip xmlns:r="http://schemas.openxmlformats.org/officeDocument/2006/relationships" xmlns:a="http://schemas.openxmlformats.org/drawingml/2006/main" r:embed="R090b82bb23214242">
             <a:alphaModFix/>
           </a:blip>
           <a:srcRect xmlns:a="http://schemas.openxmlformats.org/drawingml/2006/main" l="0" t="0" r="0" b="0"/>
@@ -26072,15 +26072,15 @@
               <a:buNone/>
             </a:pPr>
             <a:r>
-              <a:rPr sz="1250" b="0" i="0" u="none" cap="none">
+              <a:rPr sz="1500" b="1" i="0" u="none" cap="none">
                 <a:solidFill>
-                  <a:srgbClr val="5A6377"/>
+                  <a:srgbClr val="1E2447"/>
                 </a:solidFill>
                 <a:latin typeface="Calibri"/>
                 <a:ea typeface="Calibri"/>
                 <a:cs typeface="Calibri"/>
               </a:rPr>
-              <a:t>Knowledge unfolding</a:t>
+              <a:t>Knowledge Unfolding</a:t>
             </a:r>
           </a:p>
           <a:p xmlns:a="http://schemas.openxmlformats.org/drawingml/2006/main">
@@ -26094,9 +26094,9 @@
               <a:buNone/>
             </a:pPr>
             <a:r>
-              <a:rPr sz="1500" b="1" i="0" u="none" cap="none">
+              <a:rPr sz="1250" b="0" i="0" u="none" cap="none">
                 <a:solidFill>
-                  <a:srgbClr val="1E2447"/>
+                  <a:srgbClr val="5A6377"/>
                 </a:solidFill>
                 <a:latin typeface="Calibri"/>
                 <a:ea typeface="Calibri"/>
@@ -26138,9 +26138,9 @@
               <a:buNone/>
             </a:pPr>
             <a:r>
-              <a:rPr sz="1250" b="0" i="0" u="none" cap="none">
+              <a:rPr sz="1500" b="1" i="0" u="none" cap="none">
                 <a:solidFill>
-                  <a:srgbClr val="5A6377"/>
+                  <a:srgbClr val="1E2447"/>
                 </a:solidFill>
                 <a:latin typeface="Calibri"/>
                 <a:ea typeface="Calibri"/>
@@ -27588,7 +27588,7 @@
           <p:nvPr/>
         </p:nvPicPr>
         <p:blipFill rotWithShape="1">
-          <a:blip xmlns:r="http://schemas.openxmlformats.org/officeDocument/2006/relationships" xmlns:a="http://schemas.openxmlformats.org/drawingml/2006/main" r:embed="R904e13f4528a4671">
+          <a:blip xmlns:r="http://schemas.openxmlformats.org/officeDocument/2006/relationships" xmlns:a="http://schemas.openxmlformats.org/drawingml/2006/main" r:embed="R8248cd829bef4f0b">
             <a:alphaModFix/>
           </a:blip>
           <a:srcRect xmlns:a="http://schemas.openxmlformats.org/drawingml/2006/main" l="0" t="0" r="0" b="0"/>
@@ -27831,7 +27831,7 @@
           <p:nvPr/>
         </p:nvPicPr>
         <p:blipFill rotWithShape="1">
-          <a:blip xmlns:r="http://schemas.openxmlformats.org/officeDocument/2006/relationships" xmlns:a="http://schemas.openxmlformats.org/drawingml/2006/main" r:embed="Rd7c411b495c6473f">
+          <a:blip xmlns:r="http://schemas.openxmlformats.org/officeDocument/2006/relationships" xmlns:a="http://schemas.openxmlformats.org/drawingml/2006/main" r:embed="Rb88d2bc2431d496d">
             <a:alphaModFix/>
           </a:blip>
           <a:srcRect xmlns:a="http://schemas.openxmlformats.org/drawingml/2006/main" l="0" t="0" r="0" b="0"/>
@@ -28074,7 +28074,7 @@
           <p:nvPr/>
         </p:nvPicPr>
         <p:blipFill rotWithShape="1">
-          <a:blip xmlns:r="http://schemas.openxmlformats.org/officeDocument/2006/relationships" xmlns:a="http://schemas.openxmlformats.org/drawingml/2006/main" r:embed="Rec2e6fd657be42ce">
+          <a:blip xmlns:r="http://schemas.openxmlformats.org/officeDocument/2006/relationships" xmlns:a="http://schemas.openxmlformats.org/drawingml/2006/main" r:embed="R59e2eb1a3fa24ce6">
             <a:alphaModFix/>
           </a:blip>
           <a:srcRect xmlns:a="http://schemas.openxmlformats.org/drawingml/2006/main" l="0" t="0" r="0" b="0"/>
@@ -30426,7 +30426,7 @@
           <p:nvPr/>
         </p:nvPicPr>
         <p:blipFill rotWithShape="1">
-          <a:blip xmlns:r="http://schemas.openxmlformats.org/officeDocument/2006/relationships" xmlns:a="http://schemas.openxmlformats.org/drawingml/2006/main" r:embed="R680ea0bc1b1a410d">
+          <a:blip xmlns:r="http://schemas.openxmlformats.org/officeDocument/2006/relationships" xmlns:a="http://schemas.openxmlformats.org/drawingml/2006/main" r:embed="R9c2c370672c84f75">
             <a:alphaModFix/>
           </a:blip>
           <a:srcRect xmlns:a="http://schemas.openxmlformats.org/drawingml/2006/main" l="0" t="0" r="0" b="0"/>
@@ -30669,7 +30669,7 @@
           <p:nvPr/>
         </p:nvPicPr>
         <p:blipFill rotWithShape="1">
-          <a:blip xmlns:r="http://schemas.openxmlformats.org/officeDocument/2006/relationships" xmlns:a="http://schemas.openxmlformats.org/drawingml/2006/main" r:embed="Rcef0530b20e246b1">
+          <a:blip xmlns:r="http://schemas.openxmlformats.org/officeDocument/2006/relationships" xmlns:a="http://schemas.openxmlformats.org/drawingml/2006/main" r:embed="R1c410f5887264443">
             <a:alphaModFix/>
           </a:blip>
           <a:srcRect xmlns:a="http://schemas.openxmlformats.org/drawingml/2006/main" l="0" t="0" r="0" b="0"/>
@@ -30912,7 +30912,7 @@
           <p:nvPr/>
         </p:nvPicPr>
         <p:blipFill rotWithShape="1">
-          <a:blip xmlns:r="http://schemas.openxmlformats.org/officeDocument/2006/relationships" xmlns:a="http://schemas.openxmlformats.org/drawingml/2006/main" r:embed="Rabad7f0402bb41f1">
+          <a:blip xmlns:r="http://schemas.openxmlformats.org/officeDocument/2006/relationships" xmlns:a="http://schemas.openxmlformats.org/drawingml/2006/main" r:embed="Rda28c27c004943ba">
             <a:alphaModFix/>
           </a:blip>
           <a:srcRect xmlns:a="http://schemas.openxmlformats.org/drawingml/2006/main" l="0" t="0" r="0" b="0"/>

</xml_diff>